<commit_message>
Describe the phone checks as they would run in the native app
</commit_message>
<xml_diff>
--- a/deck/iRent+_解決方案.pptx
+++ b/deck/iRent+_解決方案.pptx
@@ -122,54 +122,54 @@
   <p:extLst>
     <p:ext uri="{521415D9-36F7-43E2-AB2F-B90AF26B5E84}">
       <p14:sectionLst xmlns:p14="http://schemas.microsoft.com/office/powerpoint/2010/main">
-        <p14:section name="封面" id="{ce0e526b-3ed1-71b0-ee05-21ea87b0ad4b}">
+        <p14:section name="封面" id="{a67467d2-1536-60ec-0c6c-89a6f7e7499a}">
           <p14:sldIdLst>
             <p14:sldId id="256"/>
           </p14:sldIdLst>
         </p14:section>
-        <p14:section name="提案摘要" id="{136b17fb-0244-6a9f-e40b-cb262d8c80ee}">
+        <p14:section name="提案摘要" id="{3008c7fb-78aa-155a-b8de-16a11256ad09}">
           <p14:sldIdLst>
             <p14:sldId id="257"/>
           </p14:sldIdLst>
         </p14:section>
-        <p14:section name="1. 提案概述" id="{ae48235f-3689-4d44-6728-7d5d5d3f4720}">
+        <p14:section name="1. 提案概述" id="{1a2b1900-68d4-b2f0-d033-1a811a78dd81}">
           <p14:sldIdLst>
             <p14:sldId id="258"/>
           </p14:sldIdLst>
         </p14:section>
-        <p14:section name="2. 目標對象與痛點分析" id="{6a91363a-f2b6-5d1d-11bb-1218dd40629a}">
+        <p14:section name="2. 目標對象與痛點分析" id="{589aded2-83c1-dfa5-91c3-d99f23bc5e5a}">
           <p14:sldIdLst>
             <p14:sldId id="259"/>
             <p14:sldId id="260"/>
             <p14:sldId id="261"/>
           </p14:sldIdLst>
         </p14:section>
-        <p14:section name="3. 解決方案設計" id="{f2b80a24-7385-49b9-a0f5-f42630c4c41c}">
+        <p14:section name="3. 解決方案設計" id="{f4b0859f-45d4-cd83-25fe-c0d1664a6f76}">
           <p14:sldIdLst>
             <p14:sldId id="262"/>
             <p14:sldId id="263"/>
             <p14:sldId id="264"/>
           </p14:sldIdLst>
         </p14:section>
-        <p14:section name="4. AI 應用方法" id="{47dad575-b20d-c508-afb4-5c656251038f}">
+        <p14:section name="4. AI 應用方法" id="{47094873-b767-ab62-997a-a118a595a876}">
           <p14:sldIdLst>
             <p14:sldId id="265"/>
             <p14:sldId id="266"/>
             <p14:sldId id="267"/>
           </p14:sldIdLst>
         </p14:section>
-        <p14:section name="5. 獨特優勢與差異化" id="{28633cdc-6bf8-1e6a-9fa8-3ed689e32faa}">
+        <p14:section name="5. 獨特優勢與差異化" id="{e311c407-dc1b-a133-2d7b-b47e9e09c7d7}">
           <p14:sldIdLst>
             <p14:sldId id="268"/>
           </p14:sldIdLst>
         </p14:section>
-        <p14:section name="6. 預期效益與落地評估" id="{edd96e8a-809c-5b4e-2eb1-c1a0d653afb3}">
+        <p14:section name="6. 預期效益與落地評估" id="{9cbbc8c7-9a1f-88f3-3f30-4777d23fa61d}">
           <p14:sldIdLst>
             <p14:sldId id="269"/>
             <p14:sldId id="270"/>
           </p14:sldIdLst>
         </p14:section>
-        <p14:section name="7. 補充資料" id="{c440a483-7bd4-23b2-c04f-52bbc0a9d287}">
+        <p14:section name="7. 補充資料" id="{2b2e700c-9df9-7cfd-1393-2761e56e075e}">
           <p14:sldIdLst>
             <p14:sldId id="271"/>
           </p14:sldIdLst>
@@ -1294,7 +1294,7 @@
           <a:p>
             <a:r>
               <a:rPr lang="en-US" dirty="0"/>
-              <a:t>手機端把關拍照、後台 AI 判讀車況。手機端要快，全部在瀏覽器內運算：畫質（清晰度、亮度、過曝，門檻用 1,200 張還車照片校準）；車牌（PaddleOCR 每 0.5 秒讀一次，整張車牌入鏡時 92% 讀對，從未認成別台車）；角度與遠近（比對上一張同角度照片的車牌位置與大小，站對的 95% 通過、站錯的 77% 被抓到）；光線（比上一張暗很多就提醒）。後台要準：自架 Qwen 系列視覺語言模型，看車身四角、車內、卡夾、核對用戶回報；每張判讀 3 次取多數決，整潔度意見不一取較髒，無法比對的送人工。選用原因：VLM 不必先標註大量資料；自架讓照片不外流、每天約 8.2 萬次判讀不按次付費；檢查放手機才能在用戶離開前回饋；車牌用開源 PaddleOCR，約 15 MB，在手機上執行。</a:t>
+              <a:t>手機端把關拍照、後台 AI 判讀車況。手機端要快，全部在手機上運算（App 內建模型，原型以網頁版驗證）：畫質（清晰度、亮度、過曝，門檻用 1,200 張還車照片校準）；車牌（PaddleOCR 每 0.5 秒讀一次，整張車牌入鏡時 92% 讀對，從未認成別台車）；角度與遠近（比對上一張同角度照片的車牌位置與大小，站對的 95% 通過、站錯的 77% 被抓到）；光線（比上一張暗很多就提醒）。後台要準：自架 Qwen 系列視覺語言模型，看車身四角、車內、卡夾、核對用戶回報；每張判讀 3 次取多數決，整潔度意見不一取較髒，無法比對的送人工。選用原因：VLM 不必先標註大量資料；自架讓照片不外流、每天約 8.2 萬次判讀不按次付費；檢查放手機才能在用戶離開前回饋；車牌用開源 PaddleOCR，約 15 MB，在手機上執行。</a:t>
             </a:r>
             <a:endParaRPr lang="en-US" dirty="0"/>
           </a:p>
@@ -2438,7 +2438,7 @@
           <a:p>
             <a:r>
               <a:rPr lang="en-US" dirty="0"/>
-              <a:t>取還車流程。取車：先看到這台車已記錄的損傷；拍照時疊著上一次同角度的照片，手機每 0.5 秒檢查畫質、讀車牌判斷角度與遠近、比對光線，不合格當場重拍；可補拍損傷特寫後確認取車。還車：按開始還車，計費就停止；10 分鐘內先拍卡夾和前後座，下車關門後鎖門，鎖門不用等照片上傳；再拍車外四角與停車位置。之後在歷史訂單看得到取還車確認單。這直接回應評論裡「鎖門後才要拍內部照片」的抱怨。</a:t>
+              <a:t>取還車流程。取車：先看到這台車已記錄的損傷；拍照時疊著上一次同角度的照片，手機每 0.5 秒檢查畫質、讀車牌判斷角度與遠近、比對光線，不合格當場重拍；可補拍損傷特寫後確認取車。還車：按開始還車，計費就停止；5 分鐘內先拍卡夾和前後座，下車關門後鎖門，鎖門不用等照片上傳；再拍車外四角與停車位置。之後在歷史訂單看得到取還車確認單。這直接回應評論裡「鎖門後才要拍內部照片」的抱怨。</a:t>
             </a:r>
             <a:endParaRPr lang="en-US" dirty="0"/>
           </a:p>
@@ -6440,7 +6440,7 @@
                   <a:schemeClr val="tx2"/>
                 </a:solidFill>
               </a:rPr>
-              <a:t>開源、約 15 MB，手機上每 0.5 秒辨識；畫面不上傳</a:t>
+              <a:t>開源、約 15 MB 打包進 App，每 0.5 秒辨識；畫面不上傳</a:t>
             </a:r>
             <a:endParaRPr lang="zh-TW" sz="1100" dirty="0"/>
           </a:p>
@@ -18538,7 +18538,7 @@
                           <a:ea typeface="Microsoft JhengHei" pitchFamily="34" charset="-122"/>
                           <a:cs typeface="Microsoft JhengHei" pitchFamily="34" charset="-120"/>
                         </a:rPr>
-                        <a:t>手機端：PaddleOCR PP-OCRv4 車牌辨識（onnxruntime-web）與畫質檢查，都在手機上運算；</a:t>
+                        <a:t>手機端：PaddleOCR PP-OCRv4 車牌辨識（App 用 ONNX Runtime Mobile，原型以 onnxruntime-web 驗證）與畫質檢查，都在手機上運算；</a:t>
                       </a:r>
                       <a:endParaRPr lang="en-US" sz="1350" dirty="0">
                         <a:latin typeface="Microsoft JhengHei" charset="0"/>

</xml_diff>